<commit_message>
fix: エピソード番号移動 5-5→2-3, 5-7→4-5, 5-8→4-6, 5-4→5-3
Co-Authored-By: Tatsuki Onishi <bougtoir@gmail.com>
</commit_message>
<xml_diff>
--- a/meeting-slides/meeting_slides.pptx
+++ b/meeting-slides/meeting_slides.pptx
@@ -9802,7 +9802,7 @@
               </a:defRPr>
             </a:pPr>
             <a:r>
-              <a:t>2-1〜2-2</a:t>
+              <a:t>2-1〜2-3</a:t>
             </a:r>
           </a:p>
         </p:txBody>
@@ -10112,7 +10112,7 @@
               </a:defRPr>
             </a:pPr>
             <a:r>
-              <a:t>4-1〜4-4</a:t>
+              <a:t>4-1〜4-6</a:t>
             </a:r>
           </a:p>
         </p:txBody>
@@ -10267,7 +10267,7 @@
               </a:defRPr>
             </a:pPr>
             <a:r>
-              <a:t>5-1〜5-8</a:t>
+              <a:t>5-1〜5-5</a:t>
             </a:r>
           </a:p>
         </p:txBody>
@@ -11787,6 +11787,31 @@
               <a:t>全身麻酔の機序研究 — 京都工業繊維大学（医学部なし）の論文が確信に最も近い</a:t>
             </a:r>
           </a:p>
+          <a:p>
+            <a:pPr>
+              <a:spcBef>
+                <a:spcPts val="400"/>
+              </a:spcBef>
+            </a:pPr>
+            <a:r>
+              <a:rPr sz="1500" b="1">
+                <a:solidFill>
+                  <a:srgbClr val="2C7A7B"/>
+                </a:solidFill>
+                <a:latin typeface="Yu Gothic"/>
+              </a:rPr>
+              <a:t>2-3  </a:t>
+            </a:r>
+            <a:r>
+              <a:rPr sz="1600">
+                <a:solidFill>
+                  <a:srgbClr val="1A202C"/>
+                </a:solidFill>
+                <a:latin typeface="Yu Gothic"/>
+              </a:rPr>
+              <a:t>生成AI前のプログラミングコンペ受賞歴 → コーディング能力の客観的証明</a:t>
+            </a:r>
+          </a:p>
         </p:txBody>
       </p:sp>
       <p:sp>
@@ -13150,6 +13175,56 @@
               <a:t>学術支援サービス — 導入実績あり</a:t>
             </a:r>
           </a:p>
+          <a:p>
+            <a:pPr>
+              <a:spcBef>
+                <a:spcPts val="400"/>
+              </a:spcBef>
+            </a:pPr>
+            <a:r>
+              <a:rPr sz="1500" b="1">
+                <a:solidFill>
+                  <a:srgbClr val="B7791F"/>
+                </a:solidFill>
+                <a:latin typeface="Yu Gothic"/>
+              </a:rPr>
+              <a:t>4-5  </a:t>
+            </a:r>
+            <a:r>
+              <a:rPr sz="1600">
+                <a:solidFill>
+                  <a:srgbClr val="1A202C"/>
+                </a:solidFill>
+                <a:latin typeface="Yu Gothic"/>
+              </a:rPr>
+              <a:t>大学発ベンチャー法人補助金の大学還流モデル構想</a:t>
+            </a:r>
+          </a:p>
+          <a:p>
+            <a:pPr>
+              <a:spcBef>
+                <a:spcPts val="400"/>
+              </a:spcBef>
+            </a:pPr>
+            <a:r>
+              <a:rPr sz="1500" b="1">
+                <a:solidFill>
+                  <a:srgbClr val="B7791F"/>
+                </a:solidFill>
+                <a:latin typeface="Yu Gothic"/>
+              </a:rPr>
+              <a:t>4-6  </a:t>
+            </a:r>
+            <a:r>
+              <a:rPr sz="1600">
+                <a:solidFill>
+                  <a:srgbClr val="1A202C"/>
+                </a:solidFill>
+                <a:latin typeface="Yu Gothic"/>
+              </a:rPr>
+              <a:t>産学連携 — シフト最適化・学術支援の展開</a:t>
+            </a:r>
+          </a:p>
         </p:txBody>
       </p:sp>
       <p:sp>
@@ -13549,7 +13624,7 @@
                 </a:solidFill>
                 <a:latin typeface="Yu Gothic"/>
               </a:rPr>
-              <a:t>論文管理ダッシュボードを自作 → センターのプロジェクト管理にも活用</a:t>
+              <a:t>論文を100本書いてもいいですか？</a:t>
             </a:r>
           </a:p>
           <a:p>
@@ -13574,7 +13649,7 @@
                 </a:solidFill>
                 <a:latin typeface="Yu Gothic"/>
               </a:rPr>
-              <a:t>論文を100本書いてもいいですか？</a:t>
+              <a:t>論文管理ダッシュボードを自作 → センターのプロジェクト管理にも活用</a:t>
             </a:r>
           </a:p>
           <a:p>
@@ -13599,82 +13674,7 @@
                 </a:solidFill>
                 <a:latin typeface="Yu Gothic"/>
               </a:rPr>
-              <a:t>生成AI前のプログラミングコンペ受賞歴 → コーディング能力の客観的証明</a:t>
-            </a:r>
-          </a:p>
-          <a:p>
-            <a:pPr>
-              <a:spcBef>
-                <a:spcPts val="400"/>
-              </a:spcBef>
-            </a:pPr>
-            <a:r>
-              <a:rPr sz="1500" b="1">
-                <a:solidFill>
-                  <a:srgbClr val="553C9A"/>
-                </a:solidFill>
-                <a:latin typeface="Yu Gothic"/>
-              </a:rPr>
-              <a:t>5-6  </a:t>
-            </a:r>
-            <a:r>
-              <a:rPr sz="1600">
-                <a:solidFill>
-                  <a:srgbClr val="1A202C"/>
-                </a:solidFill>
-                <a:latin typeface="Yu Gothic"/>
-              </a:rPr>
               <a:t>Devin × 伊藤忠 × 滋賀大学 — AI支援の大学導入提案</a:t>
-            </a:r>
-          </a:p>
-          <a:p>
-            <a:pPr>
-              <a:spcBef>
-                <a:spcPts val="400"/>
-              </a:spcBef>
-            </a:pPr>
-            <a:r>
-              <a:rPr sz="1500" b="1">
-                <a:solidFill>
-                  <a:srgbClr val="553C9A"/>
-                </a:solidFill>
-                <a:latin typeface="Yu Gothic"/>
-              </a:rPr>
-              <a:t>5-7  </a:t>
-            </a:r>
-            <a:r>
-              <a:rPr sz="1600">
-                <a:solidFill>
-                  <a:srgbClr val="1A202C"/>
-                </a:solidFill>
-                <a:latin typeface="Yu Gothic"/>
-              </a:rPr>
-              <a:t>大学発ベンチャー法人補助金の大学還流モデル構想</a:t>
-            </a:r>
-          </a:p>
-          <a:p>
-            <a:pPr>
-              <a:spcBef>
-                <a:spcPts val="400"/>
-              </a:spcBef>
-            </a:pPr>
-            <a:r>
-              <a:rPr sz="1500" b="1">
-                <a:solidFill>
-                  <a:srgbClr val="553C9A"/>
-                </a:solidFill>
-                <a:latin typeface="Yu Gothic"/>
-              </a:rPr>
-              <a:t>5-8  </a:t>
-            </a:r>
-            <a:r>
-              <a:rPr sz="1600">
-                <a:solidFill>
-                  <a:srgbClr val="1A202C"/>
-                </a:solidFill>
-                <a:latin typeface="Yu Gothic"/>
-              </a:rPr>
-              <a:t>産学連携 — シフト最適化・学術支援の展開</a:t>
             </a:r>
           </a:p>
         </p:txBody>

</xml_diff>